<commit_message>
Improve model performance with 80/20 temporal split, feature engineering, and Lasso tuning
- Implement chronological 80/20 train-test split
- Add lagged, rolling, and YoY feature engineering
- Standardize features for linear models
- Tune Ridge, Lasso, and tree-based models with TimeSeriesSplit
- Select Lasso as final model (R² ≈ 0.868, RMSE ≈ 0.547)
- Align Phase 2 interpretation with final model
- Update Phase 3 to use Lasso backbone for scenario forecasting
- Improve scenario responsiveness and forecasting consistency
- Refine markdown explanations and conclusions for submission
</commit_message>
<xml_diff>
--- a/project_reports/24x18_Research_Poster_Template.pptx
+++ b/project_reports/24x18_Research_Poster_Template.pptx
@@ -2666,14 +2666,15 @@
               </a:ext>
             </a:extLst>
           </a:blip>
+          <a:srcRect t="5630"/>
           <a:stretch>
             <a:fillRect/>
           </a:stretch>
         </p:blipFill>
         <p:spPr>
           <a:xfrm>
-            <a:off x="11143760" y="11724544"/>
-            <a:ext cx="4724051" cy="2970392"/>
+            <a:off x="11132688" y="12272716"/>
+            <a:ext cx="4724051" cy="2803169"/>
           </a:xfrm>
           <a:prstGeom prst="rect">
             <a:avLst/>
@@ -2907,7 +2908,7 @@
         <p:spPr bwMode="auto">
           <a:xfrm>
             <a:off x="505327" y="3466488"/>
-            <a:ext cx="4914900" cy="2926442"/>
+            <a:ext cx="4914900" cy="2680221"/>
           </a:xfrm>
           <a:prstGeom prst="rect">
             <a:avLst/>
@@ -3054,7 +3055,7 @@
           </a:p>
           <a:p>
             <a:r>
-              <a:rPr lang="en-US" sz="2000" dirty="0">
+              <a:rPr lang="en-US" sz="1800" dirty="0">
                 <a:solidFill>
                   <a:srgbClr val="000000"/>
                 </a:solidFill>
@@ -3100,7 +3101,7 @@
         <p:spPr>
           <a:xfrm>
             <a:off x="5846946" y="3357666"/>
-            <a:ext cx="4914900" cy="5142433"/>
+            <a:ext cx="4914900" cy="6004208"/>
           </a:xfrm>
           <a:prstGeom prst="rect">
             <a:avLst/>
@@ -3139,7 +3140,7 @@
           </a:p>
           <a:p>
             <a:r>
-              <a:rPr lang="en-US" sz="1600" dirty="0">
+              <a:rPr lang="en-US" sz="1800" dirty="0">
                 <a:solidFill>
                   <a:srgbClr val="000000"/>
                 </a:solidFill>
@@ -3148,7 +3149,7 @@
             </a:r>
           </a:p>
           <a:p>
-            <a:endParaRPr lang="en-US" sz="1600" dirty="0">
+            <a:endParaRPr lang="en-US" sz="1800" dirty="0">
               <a:solidFill>
                 <a:srgbClr val="000000"/>
               </a:solidFill>
@@ -3156,14 +3157,14 @@
           </a:p>
           <a:p>
             <a:r>
-              <a:rPr lang="en-US" sz="1600" b="1" dirty="0">
+              <a:rPr lang="en-US" sz="1800" b="1" dirty="0">
                 <a:solidFill>
                   <a:srgbClr val="000000"/>
                 </a:solidFill>
               </a:rPr>
               <a:t>MODEL DEVELOPMENT AND FEATURES</a:t>
             </a:r>
-            <a:endParaRPr lang="en-US" sz="1600" dirty="0">
+            <a:endParaRPr lang="en-US" sz="1800" dirty="0">
               <a:solidFill>
                 <a:srgbClr val="000000"/>
               </a:solidFill>
@@ -3175,7 +3176,7 @@
               <a:buChar char="•"/>
             </a:pPr>
             <a:r>
-              <a:rPr lang="en-US" sz="1600" dirty="0">
+              <a:rPr lang="en-US" sz="1800" dirty="0">
                 <a:solidFill>
                   <a:srgbClr val="000000"/>
                 </a:solidFill>
@@ -3189,7 +3190,7 @@
               <a:buChar char="•"/>
             </a:pPr>
             <a:r>
-              <a:rPr lang="en-US" sz="1600" dirty="0">
+              <a:rPr lang="en-US" sz="1800" dirty="0">
                 <a:solidFill>
                   <a:srgbClr val="000000"/>
                 </a:solidFill>
@@ -3203,7 +3204,7 @@
               <a:buChar char="•"/>
             </a:pPr>
             <a:r>
-              <a:rPr lang="en-US" sz="1600" dirty="0">
+              <a:rPr lang="en-US" sz="1800" dirty="0">
                 <a:solidFill>
                   <a:srgbClr val="000000"/>
                 </a:solidFill>
@@ -3217,7 +3218,7 @@
               <a:buChar char="•"/>
             </a:pPr>
             <a:r>
-              <a:rPr lang="en-US" sz="1600" dirty="0">
+              <a:rPr lang="en-US" sz="1800" dirty="0">
                 <a:solidFill>
                   <a:srgbClr val="000000"/>
                 </a:solidFill>
@@ -3226,7 +3227,7 @@
             </a:r>
           </a:p>
           <a:p>
-            <a:endParaRPr lang="en-US" sz="1600" dirty="0">
+            <a:endParaRPr lang="en-US" sz="1800" dirty="0">
               <a:solidFill>
                 <a:srgbClr val="000000"/>
               </a:solidFill>
@@ -3234,14 +3235,14 @@
           </a:p>
           <a:p>
             <a:r>
-              <a:rPr lang="en-US" sz="1600" b="1" dirty="0">
+              <a:rPr lang="en-US" sz="1800" b="1" dirty="0">
                 <a:solidFill>
                   <a:srgbClr val="000000"/>
                 </a:solidFill>
               </a:rPr>
               <a:t>MODEL SELECTION AND EVALUATION</a:t>
             </a:r>
-            <a:endParaRPr lang="en-US" sz="1600" dirty="0">
+            <a:endParaRPr lang="en-US" sz="1800" dirty="0">
               <a:solidFill>
                 <a:srgbClr val="000000"/>
               </a:solidFill>
@@ -3249,7 +3250,7 @@
           </a:p>
           <a:p>
             <a:r>
-              <a:rPr lang="en-US" sz="1600" dirty="0">
+              <a:rPr lang="en-US" sz="1800" dirty="0">
                 <a:solidFill>
                   <a:srgbClr val="000000"/>
                 </a:solidFill>
@@ -3259,7 +3260,7 @@
           </a:p>
           <a:p>
             <a:r>
-              <a:rPr lang="en-US" sz="1600" dirty="0">
+              <a:rPr lang="en-US" sz="1800" dirty="0">
                 <a:solidFill>
                   <a:srgbClr val="000000"/>
                 </a:solidFill>
@@ -3278,7 +3279,7 @@
         <p:spPr>
           <a:xfrm>
             <a:off x="425604" y="6910186"/>
-            <a:ext cx="4914900" cy="3493264"/>
+            <a:ext cx="4914900" cy="3216265"/>
           </a:xfrm>
           <a:prstGeom prst="rect">
             <a:avLst/>
@@ -3317,7 +3318,7 @@
           </a:p>
           <a:p>
             <a:r>
-              <a:rPr lang="en-US" sz="2000" dirty="0">
+              <a:rPr lang="en-US" sz="1800" dirty="0">
                 <a:solidFill>
                   <a:srgbClr val="000000"/>
                 </a:solidFill>
@@ -3331,7 +3332,7 @@
               <a:buAutoNum type="alphaUcPeriod"/>
             </a:pPr>
             <a:r>
-              <a:rPr lang="en-US" sz="2000" dirty="0">
+              <a:rPr lang="en-US" sz="1800" dirty="0">
                 <a:solidFill>
                   <a:srgbClr val="000000"/>
                 </a:solidFill>
@@ -3345,7 +3346,7 @@
               <a:buAutoNum type="alphaUcPeriod"/>
             </a:pPr>
             <a:r>
-              <a:rPr lang="en-US" sz="2000" dirty="0">
+              <a:rPr lang="en-US" sz="1800" dirty="0">
                 <a:solidFill>
                   <a:srgbClr val="000000"/>
                 </a:solidFill>
@@ -3359,7 +3360,7 @@
               <a:buAutoNum type="alphaUcPeriod"/>
             </a:pPr>
             <a:r>
-              <a:rPr lang="en-US" sz="2000" dirty="0">
+              <a:rPr lang="en-US" sz="1800" dirty="0">
                 <a:solidFill>
                   <a:srgbClr val="000000"/>
                 </a:solidFill>
@@ -3369,60 +3370,6 @@
           </a:p>
         </p:txBody>
       </p:sp>
-      <p:cxnSp>
-        <p:nvCxnSpPr>
-          <p:cNvPr id="32" name="Horizontal Section Divider" descr="Horizontal Divider"/>
-          <p:cNvCxnSpPr/>
-          <p:nvPr/>
-        </p:nvCxnSpPr>
-        <p:spPr bwMode="auto">
-          <a:xfrm>
-            <a:off x="5820548" y="8869598"/>
-            <a:ext cx="4892040" cy="0"/>
-          </a:xfrm>
-          <a:prstGeom prst="line">
-            <a:avLst/>
-          </a:prstGeom>
-          <a:noFill/>
-          <a:ln w="15875" cap="flat" cmpd="sng" algn="ctr">
-            <a:solidFill>
-              <a:schemeClr val="tx1"/>
-            </a:solidFill>
-            <a:prstDash val="dash"/>
-            <a:round/>
-            <a:headEnd type="none" w="med" len="med"/>
-            <a:tailEnd type="none" w="med" len="med"/>
-          </a:ln>
-          <a:effectLst/>
-        </p:spPr>
-      </p:cxnSp>
-      <p:cxnSp>
-        <p:nvCxnSpPr>
-          <p:cNvPr id="33" name="Horizontal Section Divider" descr="Horizontal Divider"/>
-          <p:cNvCxnSpPr/>
-          <p:nvPr/>
-        </p:nvCxnSpPr>
-        <p:spPr bwMode="auto">
-          <a:xfrm>
-            <a:off x="5829300" y="12314496"/>
-            <a:ext cx="4914900" cy="0"/>
-          </a:xfrm>
-          <a:prstGeom prst="line">
-            <a:avLst/>
-          </a:prstGeom>
-          <a:noFill/>
-          <a:ln w="15875" cap="flat" cmpd="sng" algn="ctr">
-            <a:solidFill>
-              <a:schemeClr val="tx1"/>
-            </a:solidFill>
-            <a:prstDash val="dash"/>
-            <a:round/>
-            <a:headEnd type="none" w="med" len="med"/>
-            <a:tailEnd type="none" w="med" len="med"/>
-          </a:ln>
-          <a:effectLst/>
-        </p:spPr>
-      </p:cxnSp>
       <p:cxnSp>
         <p:nvCxnSpPr>
           <p:cNvPr id="34" name="Horizontal Section Divider" descr="Horizontal Divider"/>
@@ -3459,7 +3406,7 @@
         <p:spPr>
           <a:xfrm>
             <a:off x="11192634" y="7312089"/>
-            <a:ext cx="4892040" cy="4386970"/>
+            <a:ext cx="4892040" cy="4982774"/>
           </a:xfrm>
           <a:prstGeom prst="rect">
             <a:avLst/>
@@ -3507,7 +3454,7 @@
               <a:defRPr/>
             </a:pPr>
             <a:r>
-              <a:rPr lang="en-US" sz="1600" dirty="0">
+              <a:rPr lang="en-US" sz="1800" dirty="0">
                 <a:solidFill>
                   <a:srgbClr val="000000"/>
                 </a:solidFill>
@@ -3529,7 +3476,7 @@
               <a:defRPr/>
             </a:pPr>
             <a:r>
-              <a:rPr lang="en-US" sz="1600" dirty="0">
+              <a:rPr lang="en-US" sz="1800" dirty="0">
                 <a:solidFill>
                   <a:srgbClr val="000000"/>
                 </a:solidFill>
@@ -3551,7 +3498,7 @@
         <p:spPr>
           <a:xfrm>
             <a:off x="16573222" y="3466488"/>
-            <a:ext cx="4914900" cy="4791505"/>
+            <a:ext cx="4914900" cy="5387244"/>
           </a:xfrm>
           <a:prstGeom prst="rect">
             <a:avLst/>
@@ -3599,7 +3546,7 @@
               <a:defRPr/>
             </a:pPr>
             <a:r>
-              <a:rPr lang="en-US" sz="1400" dirty="0">
+              <a:rPr lang="en-US" sz="1600" dirty="0">
                 <a:solidFill>
                   <a:srgbClr val="000000"/>
                 </a:solidFill>
@@ -3623,7 +3570,7 @@
               <a:defRPr/>
             </a:pPr>
             <a:r>
-              <a:rPr lang="en-US" sz="1400" dirty="0">
+              <a:rPr lang="en-US" sz="1600" dirty="0">
                 <a:solidFill>
                   <a:srgbClr val="000000"/>
                 </a:solidFill>
@@ -3647,7 +3594,7 @@
               <a:defRPr/>
             </a:pPr>
             <a:r>
-              <a:rPr lang="en-US" sz="1400" dirty="0">
+              <a:rPr lang="en-US" sz="1600" dirty="0">
                 <a:solidFill>
                   <a:srgbClr val="000000"/>
                 </a:solidFill>
@@ -3671,7 +3618,7 @@
               <a:defRPr/>
             </a:pPr>
             <a:r>
-              <a:rPr lang="en-US" sz="1400" dirty="0">
+              <a:rPr lang="en-US" sz="1600" dirty="0">
                 <a:solidFill>
                   <a:srgbClr val="000000"/>
                 </a:solidFill>
@@ -3692,7 +3639,7 @@
         </p:nvSpPr>
         <p:spPr>
           <a:xfrm>
-            <a:off x="16573222" y="13091510"/>
+            <a:off x="16573222" y="13287449"/>
             <a:ext cx="4868756" cy="1631216"/>
           </a:xfrm>
           <a:prstGeom prst="rect">
@@ -3975,7 +3922,7 @@
         </p:blipFill>
         <p:spPr>
           <a:xfrm>
-            <a:off x="5746217" y="12238891"/>
+            <a:off x="5799225" y="12439096"/>
             <a:ext cx="4616980" cy="2470410"/>
           </a:xfrm>
           <a:prstGeom prst="rect">
@@ -4011,7 +3958,7 @@
         </p:blipFill>
         <p:spPr>
           <a:xfrm>
-            <a:off x="5746217" y="9228649"/>
+            <a:off x="5799225" y="9477094"/>
             <a:ext cx="5040703" cy="2470410"/>
           </a:xfrm>
           <a:prstGeom prst="rect">
@@ -4052,7 +3999,7 @@
         </p:blipFill>
         <p:spPr>
           <a:xfrm>
-            <a:off x="16598215" y="8438375"/>
+            <a:off x="16598215" y="8939114"/>
             <a:ext cx="4127788" cy="1965076"/>
           </a:xfrm>
           <a:prstGeom prst="rect">
@@ -4093,7 +4040,7 @@
         </p:blipFill>
         <p:spPr>
           <a:xfrm>
-            <a:off x="16573222" y="10516619"/>
+            <a:off x="16573222" y="11017358"/>
             <a:ext cx="4105708" cy="1965076"/>
           </a:xfrm>
           <a:prstGeom prst="rect">
@@ -4106,39 +4053,6 @@
           </a:ln>
         </p:spPr>
       </p:pic>
-      <p:cxnSp>
-        <p:nvCxnSpPr>
-          <p:cNvPr id="21" name="Horizontal Section Divider" descr="Horizontal Divider">
-            <a:extLst>
-              <a:ext uri="{FF2B5EF4-FFF2-40B4-BE49-F238E27FC236}">
-                <a16:creationId xmlns:a16="http://schemas.microsoft.com/office/drawing/2014/main" id="{38637864-F803-3D30-B22C-2B5B75440366}"/>
-              </a:ext>
-            </a:extLst>
-          </p:cNvPr>
-          <p:cNvCxnSpPr/>
-          <p:nvPr/>
-        </p:nvCxnSpPr>
-        <p:spPr bwMode="auto">
-          <a:xfrm>
-            <a:off x="5829300" y="11985306"/>
-            <a:ext cx="4892040" cy="0"/>
-          </a:xfrm>
-          <a:prstGeom prst="line">
-            <a:avLst/>
-          </a:prstGeom>
-          <a:noFill/>
-          <a:ln w="15875" cap="flat" cmpd="sng" algn="ctr">
-            <a:solidFill>
-              <a:schemeClr val="tx1"/>
-            </a:solidFill>
-            <a:prstDash val="dash"/>
-            <a:round/>
-            <a:headEnd type="none" w="med" len="med"/>
-            <a:tailEnd type="none" w="med" len="med"/>
-          </a:ln>
-          <a:effectLst/>
-        </p:spPr>
-      </p:cxnSp>
       <p:pic>
         <p:nvPicPr>
           <p:cNvPr id="22" name="Picture 21" descr="A map of puerto rico with a graph and a chart&#10;&#10;AI-generated content may be incorrect.">
@@ -4167,7 +4081,7 @@
         </p:blipFill>
         <p:spPr>
           <a:xfrm>
-            <a:off x="418498" y="10775165"/>
+            <a:off x="425604" y="11096826"/>
             <a:ext cx="4810863" cy="3531439"/>
           </a:xfrm>
           <a:prstGeom prst="rect">
@@ -4189,7 +4103,7 @@
         </p:nvCxnSpPr>
         <p:spPr bwMode="auto">
           <a:xfrm>
-            <a:off x="16540490" y="12786602"/>
+            <a:off x="16540490" y="13134942"/>
             <a:ext cx="4892040" cy="0"/>
           </a:xfrm>
           <a:prstGeom prst="line">

</xml_diff>

<commit_message>
Update to Phase 4 to include other government incentives
</commit_message>
<xml_diff>
--- a/project_reports/24x18_Research_Poster_Template.pptx
+++ b/project_reports/24x18_Research_Poster_Template.pptx
@@ -208,7 +208,7 @@
           <a:p>
             <a:fld id="{D1E9724D-6106-B84D-AD73-88AB3BCE741D}" type="datetimeFigureOut">
               <a:rPr lang="en-US" smtClean="0"/>
-              <a:t>4/16/26</a:t>
+              <a:t>4/18/26</a:t>
             </a:fld>
             <a:endParaRPr lang="en-US"/>
           </a:p>
@@ -2636,7 +2636,7 @@
         </p:blipFill>
         <p:spPr>
           <a:xfrm>
-            <a:off x="5804275" y="9746509"/>
+            <a:off x="5804275" y="11040196"/>
             <a:ext cx="4835583" cy="3540940"/>
           </a:xfrm>
           <a:prstGeom prst="rect">
@@ -2908,7 +2908,7 @@
         <p:spPr bwMode="auto">
           <a:xfrm>
             <a:off x="505327" y="3466488"/>
-            <a:ext cx="4914900" cy="2926442"/>
+            <a:ext cx="4914900" cy="4773102"/>
           </a:xfrm>
           <a:prstGeom prst="rect">
             <a:avLst/>
@@ -3060,8 +3060,81 @@
                   <a:srgbClr val="000000"/>
                 </a:solidFill>
               </a:rPr>
-              <a:t>Puerto Rico has experienced sustained population decline driven by economic conditions, migration, and natural disasters. This project analyzes municipal-level population change using machine learning models and integrated socioeconomic and disaster data. The goal is to identify key drivers of population dynamics and evaluate how future trends may evolve under different conditions.</a:t>
-            </a:r>
+              <a:t>Puerto Rico has experienced sustained population decline driven by economic conditions, migration, and natural disasters. This project analyzes municipal-level population change using machine learning models and integrated socioeconomic and disaster data. </a:t>
+            </a:r>
+          </a:p>
+          <a:p>
+            <a:endParaRPr lang="en-US" sz="2000" dirty="0">
+              <a:solidFill>
+                <a:srgbClr val="000000"/>
+              </a:solidFill>
+            </a:endParaRPr>
+          </a:p>
+          <a:p>
+            <a:r>
+              <a:rPr lang="en-US" sz="2000" b="1" dirty="0">
+                <a:solidFill>
+                  <a:srgbClr val="000000"/>
+                </a:solidFill>
+              </a:rPr>
+              <a:t>Objective: </a:t>
+            </a:r>
+            <a:r>
+              <a:rPr lang="en-US" sz="2000" dirty="0">
+                <a:solidFill>
+                  <a:srgbClr val="000000"/>
+                </a:solidFill>
+              </a:rPr>
+              <a:t>Identify key drivers of population dynamics and evaluate how future trends may evolve under different conditions. Provide customer with Interactive Dashboard: </a:t>
+            </a:r>
+            <a:r>
+              <a:rPr lang="en-US" sz="1800" dirty="0">
+                <a:solidFill>
+                  <a:srgbClr val="000000"/>
+                </a:solidFill>
+                <a:hlinkClick r:id="rId5"/>
+              </a:rPr>
+              <a:t>https://</a:t>
+            </a:r>
+            <a:r>
+              <a:rPr lang="en-US" sz="1800" dirty="0" err="1">
+                <a:solidFill>
+                  <a:srgbClr val="000000"/>
+                </a:solidFill>
+                <a:hlinkClick r:id="rId5"/>
+              </a:rPr>
+              <a:t>venettov.github.io</a:t>
+            </a:r>
+            <a:r>
+              <a:rPr lang="en-US" sz="1800" dirty="0">
+                <a:solidFill>
+                  <a:srgbClr val="000000"/>
+                </a:solidFill>
+                <a:hlinkClick r:id="rId5"/>
+              </a:rPr>
+              <a:t>/CAPSTONE_DATA_SCIENCE_RIVERARUIZ/</a:t>
+            </a:r>
+            <a:r>
+              <a:rPr lang="en-US" sz="1800" dirty="0" err="1">
+                <a:solidFill>
+                  <a:srgbClr val="000000"/>
+                </a:solidFill>
+                <a:hlinkClick r:id="rId5"/>
+              </a:rPr>
+              <a:t>dashboards.html</a:t>
+            </a:r>
+            <a:endParaRPr lang="en-US" sz="1800" dirty="0">
+              <a:solidFill>
+                <a:srgbClr val="000000"/>
+              </a:solidFill>
+            </a:endParaRPr>
+          </a:p>
+          <a:p>
+            <a:endParaRPr lang="en-US" sz="2000" dirty="0">
+              <a:solidFill>
+                <a:srgbClr val="000000"/>
+              </a:solidFill>
+            </a:endParaRPr>
           </a:p>
         </p:txBody>
       </p:sp>
@@ -3073,7 +3146,7 @@
         </p:nvCxnSpPr>
         <p:spPr bwMode="auto">
           <a:xfrm>
-            <a:off x="473075" y="6738595"/>
+            <a:off x="448502" y="8021894"/>
             <a:ext cx="4794664" cy="0"/>
           </a:xfrm>
           <a:prstGeom prst="line">
@@ -3101,7 +3174,7 @@
         <p:spPr>
           <a:xfrm>
             <a:off x="5846946" y="3357666"/>
-            <a:ext cx="4914900" cy="6004208"/>
+            <a:ext cx="4914900" cy="7389202"/>
           </a:xfrm>
           <a:prstGeom prst="rect">
             <a:avLst/>
@@ -3145,7 +3218,7 @@
                   <a:srgbClr val="000000"/>
                 </a:solidFill>
               </a:rPr>
-              <a:t>Municipal population change is modeled using a 3-year forward target to capture longer-term dynamics and reduce short-term noise. Data are split using a time-based approach (train ≤2018, validation=2019, test ≥2020) to preserve temporal structure:</a:t>
+              <a:t>Municipal population change is modeled using a 3-year forward target to capture longer-term dynamics. A chronological split (train ≤2018, validation=2019, test ≥2020) preserves temporal structure and avoids data leakage. A Lasso model is trained on lagged population, economic, demographic, and vulnerability features, with interpretability assessed using coefficients and SHAP analysis.</a:t>
             </a:r>
           </a:p>
           <a:p>
@@ -3255,7 +3328,7 @@
                   <a:srgbClr val="000000"/>
                 </a:solidFill>
               </a:rPr>
-              <a:t>Compared linear and nonlinear models (OLS, Ridge, Random Forest, Extra Trees) </a:t>
+              <a:t>Compared linear and nonlinear models.</a:t>
             </a:r>
           </a:p>
           <a:p>
@@ -3265,7 +3338,7 @@
                   <a:srgbClr val="000000"/>
                 </a:solidFill>
               </a:rPr>
-              <a:t>Selected Extra Trees for stability and nonlinear modeling capability</a:t>
+              <a:t>Selected Lasso based on strongest out-of-sample performance under a chronological split, providing a stable and interpretable model aligned with lag-driven population dynamics.</a:t>
             </a:r>
           </a:p>
         </p:txBody>
@@ -3278,8 +3351,8 @@
         </p:nvSpPr>
         <p:spPr>
           <a:xfrm>
-            <a:off x="425604" y="6910186"/>
-            <a:ext cx="4914900" cy="3493264"/>
+            <a:off x="425604" y="8030424"/>
+            <a:ext cx="4914900" cy="3216265"/>
           </a:xfrm>
           <a:prstGeom prst="rect">
             <a:avLst/>
@@ -3318,7 +3391,7 @@
           </a:p>
           <a:p>
             <a:r>
-              <a:rPr lang="en-US" sz="2000" dirty="0">
+              <a:rPr lang="en-US" sz="1800" dirty="0">
                 <a:solidFill>
                   <a:srgbClr val="000000"/>
                 </a:solidFill>
@@ -3332,7 +3405,7 @@
               <a:buAutoNum type="alphaUcPeriod"/>
             </a:pPr>
             <a:r>
-              <a:rPr lang="en-US" sz="2000" dirty="0">
+              <a:rPr lang="en-US" sz="1800" dirty="0">
                 <a:solidFill>
                   <a:srgbClr val="000000"/>
                 </a:solidFill>
@@ -3346,7 +3419,7 @@
               <a:buAutoNum type="alphaUcPeriod"/>
             </a:pPr>
             <a:r>
-              <a:rPr lang="en-US" sz="2000" dirty="0">
+              <a:rPr lang="en-US" sz="1800" dirty="0">
                 <a:solidFill>
                   <a:srgbClr val="000000"/>
                 </a:solidFill>
@@ -3360,7 +3433,7 @@
               <a:buAutoNum type="alphaUcPeriod"/>
             </a:pPr>
             <a:r>
-              <a:rPr lang="en-US" sz="2000" dirty="0">
+              <a:rPr lang="en-US" sz="1800" dirty="0">
                 <a:solidFill>
                   <a:srgbClr val="000000"/>
                 </a:solidFill>
@@ -3821,53 +3894,6 @@
       </p:sp>
       <p:pic>
         <p:nvPicPr>
-          <p:cNvPr id="1028" name="Picture 4" descr="University Seal Use - University Seal Use">
-            <a:extLst>
-              <a:ext uri="{FF2B5EF4-FFF2-40B4-BE49-F238E27FC236}">
-                <a16:creationId xmlns:a16="http://schemas.microsoft.com/office/drawing/2014/main" id="{850DBD5C-2D65-2131-3B0E-3B204D897B74}"/>
-              </a:ext>
-            </a:extLst>
-          </p:cNvPr>
-          <p:cNvPicPr>
-            <a:picLocks noChangeAspect="1" noChangeArrowheads="1"/>
-          </p:cNvPicPr>
-          <p:nvPr/>
-        </p:nvPicPr>
-        <p:blipFill>
-          <a:blip r:embed="rId5">
-            <a:extLst>
-              <a:ext uri="{28A0092B-C50C-407E-A947-70E740481C1C}">
-                <a14:useLocalDpi xmlns:a14="http://schemas.microsoft.com/office/drawing/2010/main" val="0"/>
-              </a:ext>
-            </a:extLst>
-          </a:blip>
-          <a:srcRect/>
-          <a:stretch>
-            <a:fillRect/>
-          </a:stretch>
-        </p:blipFill>
-        <p:spPr bwMode="auto">
-          <a:xfrm>
-            <a:off x="18979573" y="302375"/>
-            <a:ext cx="2177882" cy="2177882"/>
-          </a:xfrm>
-          <a:prstGeom prst="rect">
-            <a:avLst/>
-          </a:prstGeom>
-          <a:noFill/>
-          <a:extLst>
-            <a:ext uri="{909E8E84-426E-40DD-AFC4-6F175D3DCCD1}">
-              <a14:hiddenFill xmlns:a14="http://schemas.microsoft.com/office/drawing/2010/main">
-                <a:solidFill>
-                  <a:srgbClr val="FFFFFF"/>
-                </a:solidFill>
-              </a14:hiddenFill>
-            </a:ext>
-          </a:extLst>
-        </p:spPr>
-      </p:pic>
-      <p:pic>
-        <p:nvPicPr>
           <p:cNvPr id="15" name="Picture 14">
             <a:extLst>
               <a:ext uri="{FF2B5EF4-FFF2-40B4-BE49-F238E27FC236}">
@@ -3894,8 +3920,8 @@
         </p:blipFill>
         <p:spPr>
           <a:xfrm>
-            <a:off x="11481651" y="11880007"/>
-            <a:ext cx="4127788" cy="1965076"/>
+            <a:off x="11169830" y="11828127"/>
+            <a:ext cx="4591925" cy="2186033"/>
           </a:xfrm>
           <a:prstGeom prst="rect">
             <a:avLst/>
@@ -3935,7 +3961,7 @@
         </p:blipFill>
         <p:spPr>
           <a:xfrm>
-            <a:off x="425604" y="11096826"/>
+            <a:off x="425604" y="11205879"/>
             <a:ext cx="4810863" cy="3531439"/>
           </a:xfrm>
           <a:prstGeom prst="rect">
@@ -3998,12 +4024,51 @@
         </p:blipFill>
         <p:spPr>
           <a:xfrm>
-            <a:off x="16451232" y="9951125"/>
+            <a:off x="16482874" y="10018583"/>
             <a:ext cx="4809405" cy="2571655"/>
           </a:xfrm>
           <a:prstGeom prst="rect">
             <a:avLst/>
           </a:prstGeom>
+        </p:spPr>
+      </p:pic>
+      <p:pic>
+        <p:nvPicPr>
+          <p:cNvPr id="2" name="Picture 9">
+            <a:extLst>
+              <a:ext uri="{FF2B5EF4-FFF2-40B4-BE49-F238E27FC236}">
+                <a16:creationId xmlns:a16="http://schemas.microsoft.com/office/drawing/2014/main" id="{E754C0C9-0440-89F8-BD44-90AA4D9CCB9D}"/>
+              </a:ext>
+            </a:extLst>
+          </p:cNvPr>
+          <p:cNvPicPr>
+            <a:picLocks noChangeAspect="1" noChangeArrowheads="1"/>
+          </p:cNvPicPr>
+          <p:nvPr/>
+        </p:nvPicPr>
+        <p:blipFill>
+          <a:blip r:embed="rId9"/>
+          <a:srcRect/>
+          <a:stretch/>
+        </p:blipFill>
+        <p:spPr bwMode="auto">
+          <a:xfrm>
+            <a:off x="15907571" y="603008"/>
+            <a:ext cx="5073790" cy="1504088"/>
+          </a:xfrm>
+          <a:prstGeom prst="rect">
+            <a:avLst/>
+          </a:prstGeom>
+          <a:noFill/>
+          <a:extLst>
+            <a:ext uri="{909E8E84-426E-40DD-AFC4-6F175D3DCCD1}">
+              <a14:hiddenFill xmlns:a14="http://schemas.microsoft.com/office/drawing/2010/main">
+                <a:solidFill>
+                  <a:srgbClr val="FFFFFF"/>
+                </a:solidFill>
+              </a14:hiddenFill>
+            </a:ext>
+          </a:extLst>
         </p:spPr>
       </p:pic>
     </p:spTree>

</xml_diff>